<commit_message>
第六週第2節：第12張補 Rate Noise Density 與 Unmanned and autonomous vehicles 的說明
- 備忘稿：雜訊密度＝讀數忽上忽下的程度，和零偏的差別（體重計例子）；Applications 那一欄翻成無人載具與自駕載具
- 講義 IMU 對照表加雜訊密度一列、術語表加一條；中越兩版與 PDF 重產

Co-Authored-By: Claude Opus 5.5 <noreply@anthropic.com>
</commit_message>
<xml_diff>
--- a/第六週(10-15)/第六週_第2節_簡報.pptx
+++ b/第六週(10-15)/第六週_第2節_簡報.pptx
@@ -1878,11 +1878,11 @@
                 <a:spcPts val="0"/>
               </a:spcBef>
               <a:spcAft>
-                <a:spcPts val="183"/>
+                <a:spcPts val="158"/>
               </a:spcAft>
             </a:pPr>
             <a:r>
-              <a:rPr sz="1100" lang="zh-TW" dirty="0">
+              <a:rPr sz="950" lang="zh-TW" dirty="0">
                 <a:solidFill>
                   <a:srgbClr val="000000"/>
                 </a:solidFill>
@@ -1893,7 +1893,7 @@
               <a:t>第二顆，Analog Devices 的 </a:t>
             </a:r>
             <a:r>
-              <a:rPr sz="1100" b="1" lang="zh-TW" dirty="0">
+              <a:rPr sz="950" b="1" lang="zh-TW" dirty="0">
                 <a:solidFill>
                   <a:srgbClr val="000000"/>
                 </a:solidFill>
@@ -1904,7 +1904,7 @@
               <a:t>ADIS16470</a:t>
             </a:r>
             <a:r>
-              <a:rPr sz="1100" lang="zh-TW" dirty="0">
+              <a:rPr sz="950" lang="zh-TW" dirty="0">
                 <a:solidFill>
                   <a:srgbClr val="000000"/>
                 </a:solidFill>
@@ -1922,11 +1922,11 @@
                 <a:spcPts val="0"/>
               </a:spcBef>
               <a:spcAft>
-                <a:spcPts val="183"/>
+                <a:spcPts val="158"/>
               </a:spcAft>
             </a:pPr>
             <a:r>
-              <a:rPr sz="1100" lang="zh-TW" dirty="0">
+              <a:rPr sz="950" lang="zh-TW" dirty="0">
                 <a:solidFill>
                   <a:srgbClr val="000000"/>
                 </a:solidFill>
@@ -1937,7 +1937,7 @@
               <a:t>從上往下。</a:t>
             </a:r>
             <a:r>
-              <a:rPr sz="1100" b="1" lang="zh-TW" dirty="0">
+              <a:rPr sz="950" b="1" lang="zh-TW" dirty="0">
                 <a:solidFill>
                   <a:srgbClr val="000000"/>
                 </a:solidFill>
@@ -1948,7 +1948,7 @@
               <a:t>Dynamic Range，±2000 °/sec。</a:t>
             </a:r>
             <a:r>
-              <a:rPr sz="1100" lang="zh-TW" dirty="0">
+              <a:rPr sz="950" lang="zh-TW" dirty="0">
                 <a:solidFill>
                   <a:srgbClr val="000000"/>
                 </a:solidFill>
@@ -1959,7 +1959,7 @@
               <a:t>各位可能會想：上週相機也有動態範圍，那是同一件事嗎？</a:t>
             </a:r>
             <a:r>
-              <a:rPr sz="1100" b="1" lang="zh-TW" dirty="0">
+              <a:rPr sz="950" b="1" lang="zh-TW" dirty="0">
                 <a:solidFill>
                   <a:srgbClr val="000000"/>
                 </a:solidFill>
@@ -1970,7 +1970,7 @@
               <a:t>不是。</a:t>
             </a:r>
             <a:r>
-              <a:rPr sz="1100" lang="zh-TW" dirty="0">
+              <a:rPr sz="950" lang="zh-TW" dirty="0">
                 <a:solidFill>
                   <a:srgbClr val="000000"/>
                 </a:solidFill>
@@ -1981,7 +1981,7 @@
               <a:t>上週相機的動態範圍，講的是最亮和最暗差多少倍，單位是 dB，逆光、隧道口就看它。這裡的 Dynamic Range，看單位是 °/sec，講的是最快量得到轉多快，就是剛剛 TDK 那張表叫 </a:t>
             </a:r>
             <a:r>
-              <a:rPr sz="1100" b="1" lang="zh-TW" dirty="0">
+              <a:rPr sz="950" b="1" lang="zh-TW" dirty="0">
                 <a:solidFill>
                   <a:srgbClr val="000000"/>
                 </a:solidFill>
@@ -1992,7 +1992,7 @@
               <a:t>Full-Scale Range</a:t>
             </a:r>
             <a:r>
-              <a:rPr sz="1100" lang="zh-TW" dirty="0">
+              <a:rPr sz="950" lang="zh-TW" dirty="0">
                 <a:solidFill>
                   <a:srgbClr val="000000"/>
                 </a:solidFill>
@@ -2003,7 +2003,7 @@
               <a:t> 的那一行，量程。兩家公司用不同的名字講同一件事；同一個英文詞，放在不同感測器上，意思也可能不一樣。所以讀規格表，</a:t>
             </a:r>
             <a:r>
-              <a:rPr sz="1100" b="1" lang="zh-TW" dirty="0">
+              <a:rPr sz="950" b="1" lang="zh-TW" dirty="0">
                 <a:solidFill>
                   <a:srgbClr val="000000"/>
                 </a:solidFill>
@@ -2014,7 +2014,7 @@
               <a:t>先看單位</a:t>
             </a:r>
             <a:r>
-              <a:rPr sz="1100" lang="zh-TW" dirty="0">
+              <a:rPr sz="950" lang="zh-TW" dirty="0">
                 <a:solidFill>
                   <a:srgbClr val="000000"/>
                 </a:solidFill>
@@ -2032,11 +2032,11 @@
                 <a:spcPts val="0"/>
               </a:spcBef>
               <a:spcAft>
-                <a:spcPts val="183"/>
+                <a:spcPts val="158"/>
               </a:spcAft>
             </a:pPr>
             <a:r>
-              <a:rPr sz="1100" lang="zh-TW" dirty="0">
+              <a:rPr sz="950" lang="zh-TW" dirty="0">
                 <a:solidFill>
                   <a:srgbClr val="000000"/>
                 </a:solidFill>
@@ -2054,11 +2054,11 @@
                 <a:spcPts val="0"/>
               </a:spcBef>
               <a:spcAft>
-                <a:spcPts val="183"/>
+                <a:spcPts val="158"/>
               </a:spcAft>
             </a:pPr>
             <a:r>
-              <a:rPr sz="1100" lang="zh-TW" dirty="0">
+              <a:rPr sz="950" lang="zh-TW" dirty="0">
                 <a:solidFill>
                   <a:srgbClr val="000000"/>
                 </a:solidFill>
@@ -2069,7 +2069,7 @@
               <a:t>往下看 </a:t>
             </a:r>
             <a:r>
-              <a:rPr sz="1100" b="1" lang="zh-TW" dirty="0">
+              <a:rPr sz="950" b="1" lang="zh-TW" dirty="0">
                 <a:solidFill>
                   <a:srgbClr val="000000"/>
                 </a:solidFill>
@@ -2080,7 +2080,7 @@
               <a:t>Bias</a:t>
             </a:r>
             <a:r>
-              <a:rPr sz="1100" lang="zh-TW" dirty="0">
+              <a:rPr sz="950" lang="zh-TW" dirty="0">
                 <a:solidFill>
                   <a:srgbClr val="000000"/>
                 </a:solidFill>
@@ -2091,7 +2091,7 @@
               <a:t> 那一塊，前兩列就是剛剛手機級找不到的。</a:t>
             </a:r>
             <a:r>
-              <a:rPr sz="1100" b="1" lang="zh-TW" dirty="0">
+              <a:rPr sz="950" b="1" lang="zh-TW" dirty="0">
                 <a:solidFill>
                   <a:srgbClr val="000000"/>
                 </a:solidFill>
@@ -2102,7 +2102,7 @@
               <a:t>In Run Stability，8 °/hr</a:t>
             </a:r>
             <a:r>
-              <a:rPr sz="1100" lang="zh-TW" dirty="0">
+              <a:rPr sz="950" lang="zh-TW" dirty="0">
                 <a:solidFill>
                   <a:srgbClr val="000000"/>
                 </a:solidFill>
@@ -2113,7 +2113,7 @@
               <a:t>，後面寫 1 σ。σ 是希臘字母，唸「西格瑪」，越南文唸 xích-ma。1 σ 是統計上的一個標準差，意思是大約七成的時候落在這個數字以內。跟上一張的 CEP 50%、上週光達的 &gt;90% 一樣，是機率的寫法，不是保證。8 °/hr 的意思是這顆靜止放著，一個小時偏差只飄八度，一分鐘零點一三度。用手錶來想：便宜的錶一天可能差一分鐘，好的錶一個月才差幾秒。偏差穩定度講的就是這種「走久了會差多少」。</a:t>
             </a:r>
             <a:r>
-              <a:rPr sz="1100" b="1" lang="zh-TW" dirty="0">
+              <a:rPr sz="950" b="1" lang="zh-TW" dirty="0">
                 <a:solidFill>
                   <a:srgbClr val="000000"/>
                 </a:solidFill>
@@ -2124,7 +2124,7 @@
               <a:t>Angular Random Walk，0.34 °/√hr</a:t>
             </a:r>
             <a:r>
-              <a:rPr sz="1100" lang="zh-TW" dirty="0">
+              <a:rPr sz="950" lang="zh-TW" dirty="0">
                 <a:solidFill>
                   <a:srgbClr val="000000"/>
                 </a:solidFill>
@@ -2142,11 +2142,11 @@
                 <a:spcPts val="0"/>
               </a:spcBef>
               <a:spcAft>
-                <a:spcPts val="183"/>
+                <a:spcPts val="158"/>
               </a:spcAft>
             </a:pPr>
             <a:r>
-              <a:rPr sz="1100" lang="zh-TW" dirty="0">
+              <a:rPr sz="950" lang="zh-TW" dirty="0">
                 <a:solidFill>
                   <a:srgbClr val="000000"/>
                 </a:solidFill>
@@ -2157,26 +2157,70 @@
               <a:t>再看 </a:t>
             </a:r>
             <a:r>
-              <a:rPr sz="1100" b="1" lang="zh-TW" dirty="0">
-                <a:solidFill>
-                  <a:srgbClr val="000000"/>
-                </a:solidFill>
-                <a:latin typeface="Arial Unicode MS"/>
-                <a:ea typeface="Arial Unicode MS"/>
-                <a:cs typeface="Arial Unicode MS"/>
-              </a:rPr>
-              <a:t>Rate Noise Density，0.008</a:t>
-            </a:r>
-            <a:r>
-              <a:rPr sz="1100" lang="zh-TW" dirty="0">
-                <a:solidFill>
-                  <a:srgbClr val="000000"/>
-                </a:solidFill>
-                <a:latin typeface="Arial Unicode MS"/>
-                <a:ea typeface="Arial Unicode MS"/>
-                <a:cs typeface="Arial Unicode MS"/>
-              </a:rPr>
-              <a:t>。手機級那顆是 0.015，差一倍。這一行兩邊的表都有，可以直接比；Bias 那兩行只有這邊有。
+              <a:rPr sz="950" b="1" lang="zh-TW" dirty="0">
+                <a:solidFill>
+                  <a:srgbClr val="000000"/>
+                </a:solidFill>
+                <a:latin typeface="Arial Unicode MS"/>
+                <a:ea typeface="Arial Unicode MS"/>
+                <a:cs typeface="Arial Unicode MS"/>
+              </a:rPr>
+              <a:t>Rate Noise Density，雜訊密度，0.008</a:t>
+            </a:r>
+            <a:r>
+              <a:rPr sz="950" lang="zh-TW" dirty="0">
+                <a:solidFill>
+                  <a:srgbClr val="000000"/>
+                </a:solidFill>
+                <a:latin typeface="Arial Unicode MS"/>
+                <a:ea typeface="Arial Unicode MS"/>
+                <a:cs typeface="Arial Unicode MS"/>
+              </a:rPr>
+              <a:t>，單位是度每秒、再除以根號赫茲。它講的是讀數一直在「抖」的程度：東西靜止，讀數卻一下 +0.02、一下 −0.03，跳來跳去。這跟剛剛的零偏不一樣。用體重計來想：沒人站上去也顯示兩公斤，是</a:t>
+            </a:r>
+            <a:r>
+              <a:rPr sz="950" b="1" lang="zh-TW" dirty="0">
+                <a:solidFill>
+                  <a:srgbClr val="000000"/>
+                </a:solidFill>
+                <a:latin typeface="Arial Unicode MS"/>
+                <a:ea typeface="Arial Unicode MS"/>
+                <a:cs typeface="Arial Unicode MS"/>
+              </a:rPr>
+              <a:t>零偏</a:t>
+            </a:r>
+            <a:r>
+              <a:rPr sz="950" lang="zh-TW" dirty="0">
+                <a:solidFill>
+                  <a:srgbClr val="000000"/>
+                </a:solidFill>
+                <a:latin typeface="Arial Unicode MS"/>
+                <a:ea typeface="Arial Unicode MS"/>
+                <a:cs typeface="Arial Unicode MS"/>
+              </a:rPr>
+              <a:t>，一直偏同一邊；人站上去，數字在 60.1、59.9、60.2 之間跳，是</a:t>
+            </a:r>
+            <a:r>
+              <a:rPr sz="950" b="1" lang="zh-TW" dirty="0">
+                <a:solidFill>
+                  <a:srgbClr val="000000"/>
+                </a:solidFill>
+                <a:latin typeface="Arial Unicode MS"/>
+                <a:ea typeface="Arial Unicode MS"/>
+                <a:cs typeface="Arial Unicode MS"/>
+              </a:rPr>
+              <a:t>雜訊</a:t>
+            </a:r>
+            <a:r>
+              <a:rPr sz="950" lang="zh-TW" dirty="0">
+                <a:solidFill>
+                  <a:srgbClr val="000000"/>
+                </a:solidFill>
+                <a:latin typeface="Arial Unicode MS"/>
+                <a:ea typeface="Arial Unicode MS"/>
+                <a:cs typeface="Arial Unicode MS"/>
+              </a:rPr>
+              <a:t>，忽上忽下。零偏可以先量出來扣掉，雜訊扣不掉，只能平均。單位裡的「除以根號赫茲」是說：你要的更新愈快，抖得愈厲害。手機級那顆是 0.015，大約差一倍。這一行兩邊的表都有，可以直接比；Bias 那兩行只有這邊有。
 </a:t>
             </a:r>
           </a:p>
@@ -2186,22 +2230,22 @@
                 <a:spcPts val="0"/>
               </a:spcBef>
               <a:spcAft>
-                <a:spcPts val="183"/>
+                <a:spcPts val="158"/>
               </a:spcAft>
             </a:pPr>
             <a:r>
-              <a:rPr sz="1100" lang="zh-TW" dirty="0">
-                <a:solidFill>
-                  <a:srgbClr val="000000"/>
-                </a:solidFill>
-                <a:latin typeface="Arial Unicode MS"/>
-                <a:ea typeface="Arial Unicode MS"/>
-                <a:cs typeface="Arial Unicode MS"/>
-              </a:rPr>
-              <a:t>翻回規格書第一頁，Applications 那一欄寫的是 Navigation、</a:t>
-            </a:r>
-            <a:r>
-              <a:rPr sz="1100" b="1" lang="zh-TW" dirty="0">
+              <a:rPr sz="950" lang="zh-TW" dirty="0">
+                <a:solidFill>
+                  <a:srgbClr val="000000"/>
+                </a:solidFill>
+                <a:latin typeface="Arial Unicode MS"/>
+                <a:ea typeface="Arial Unicode MS"/>
+                <a:cs typeface="Arial Unicode MS"/>
+              </a:rPr>
+              <a:t>翻回規格書第一頁，Applications 那一欄寫的是 Navigation（導航）、</a:t>
+            </a:r>
+            <a:r>
+              <a:rPr sz="950" b="1" lang="zh-TW" dirty="0">
                 <a:solidFill>
                   <a:srgbClr val="000000"/>
                 </a:solidFill>
@@ -2212,15 +2256,37 @@
               <a:t>Unmanned and autonomous vehicles</a:t>
             </a:r>
             <a:r>
-              <a:rPr sz="1100" lang="zh-TW" dirty="0">
-                <a:solidFill>
-                  <a:srgbClr val="000000"/>
-                </a:solidFill>
-                <a:latin typeface="Arial Unicode MS"/>
-                <a:ea typeface="Arial Unicode MS"/>
-                <a:cs typeface="Arial Unicode MS"/>
-              </a:rPr>
-              <a:t>、robotics。手機級那顆寫的是 Smartphones。規格書自己告訴你它是給誰用的。
+              <a:rPr sz="950" lang="zh-TW" dirty="0">
+                <a:solidFill>
+                  <a:srgbClr val="000000"/>
+                </a:solidFill>
+                <a:latin typeface="Arial Unicode MS"/>
+                <a:ea typeface="Arial Unicode MS"/>
+                <a:cs typeface="Arial Unicode MS"/>
+              </a:rPr>
+              <a:t>、robotics（機器人）。中間那個是「</a:t>
+            </a:r>
+            <a:r>
+              <a:rPr sz="950" b="1" lang="zh-TW" dirty="0">
+                <a:solidFill>
+                  <a:srgbClr val="000000"/>
+                </a:solidFill>
+                <a:latin typeface="Arial Unicode MS"/>
+                <a:ea typeface="Arial Unicode MS"/>
+                <a:cs typeface="Arial Unicode MS"/>
+              </a:rPr>
+              <a:t>無人載具與自駕載具</a:t>
+            </a:r>
+            <a:r>
+              <a:rPr sz="950" lang="zh-TW" dirty="0">
+                <a:solidFill>
+                  <a:srgbClr val="000000"/>
+                </a:solidFill>
+                <a:latin typeface="Arial Unicode MS"/>
+                <a:ea typeface="Arial Unicode MS"/>
+                <a:cs typeface="Arial Unicode MS"/>
+              </a:rPr>
+              <a:t>」：unmanned 是裡面沒有人在開，像無人機、工廠裡的無人搬運車；autonomous 是自己判斷、自己開，像自駕車。底下的結論條寫的就是這一句。手機級那顆寫的是 Smartphones。規格書自己告訴你它是給誰用的。
 </a:t>
             </a:r>
           </a:p>
@@ -2230,11 +2296,11 @@
                 <a:spcPts val="0"/>
               </a:spcBef>
               <a:spcAft>
-                <a:spcPts val="183"/>
+                <a:spcPts val="158"/>
               </a:spcAft>
             </a:pPr>
             <a:r>
-              <a:rPr sz="1100" lang="zh-TW" dirty="0">
+              <a:rPr sz="950" lang="zh-TW" dirty="0">
                 <a:solidFill>
                   <a:srgbClr val="000000"/>
                 </a:solidFill>

</xml_diff>